<commit_message>
Expense & Reimbursement Agent: AI-native reimbursement assistant (Track 1)
</commit_message>
<xml_diff>
--- a/docs/Expense_Agent_Deck.pptx
+++ b/docs/Expense_Agent_Deck.pptx
@@ -5,18 +5,18 @@
     <p:sldMasterId id="2147483648" r:id="rId1"/>
   </p:sldMasterIdLst>
   <p:sldIdLst>
-    <p:sldId id="256" r:id="rId7"/>
-    <p:sldId id="257" r:id="rId8"/>
-    <p:sldId id="258" r:id="rId9"/>
-    <p:sldId id="259" r:id="rId10"/>
-    <p:sldId id="260" r:id="rId11"/>
-    <p:sldId id="261" r:id="rId12"/>
-    <p:sldId id="262" r:id="rId13"/>
-    <p:sldId id="263" r:id="rId14"/>
-    <p:sldId id="264" r:id="rId15"/>
-    <p:sldId id="265" r:id="rId16"/>
+    <p:sldId id="256" r:id="rId2"/>
+    <p:sldId id="257" r:id="rId3"/>
+    <p:sldId id="258" r:id="rId4"/>
+    <p:sldId id="259" r:id="rId5"/>
+    <p:sldId id="260" r:id="rId6"/>
+    <p:sldId id="261" r:id="rId7"/>
+    <p:sldId id="262" r:id="rId8"/>
+    <p:sldId id="263" r:id="rId9"/>
+    <p:sldId id="264" r:id="rId10"/>
+    <p:sldId id="265" r:id="rId11"/>
   </p:sldIdLst>
-  <p:sldSz cx="12191695" cy="6858000" type="screen4x3"/>
+  <p:sldSz cx="12192000" cy="6858000"/>
   <p:notesSz cx="6858000" cy="9144000"/>
   <p:defaultTextStyle>
     <a:defPPr>
@@ -113,6 +113,22 @@
       </a:defRPr>
     </a:lvl9pPr>
   </p:defaultTextStyle>
+  <p:extLst>
+    <p:ext uri="{EFAFB233-063F-42B5-8137-9DF3F51BA10A}">
+      <p15:sldGuideLst xmlns:p15="http://schemas.microsoft.com/office/powerpoint/2012/main">
+        <p15:guide id="1" orient="horz" pos="2160">
+          <p15:clr>
+            <a:srgbClr val="A4A3A4"/>
+          </p15:clr>
+        </p15:guide>
+        <p15:guide id="2" pos="2880">
+          <p15:clr>
+            <a:srgbClr val="A4A3A4"/>
+          </p15:clr>
+        </p15:guide>
+      </p15:sldGuideLst>
+    </p:ext>
+  </p:extLst>
 </p:presentation>
 </file>
 
@@ -154,10 +170,9 @@
           <a:lstStyle/>
           <a:p>
             <a:r>
-              <a:rPr lang="en-US" smtClean="0"/>
+              <a:rPr lang="en-US"/>
               <a:t>Click to edit Master title style</a:t>
             </a:r>
-            <a:endParaRPr lang="en-US"/>
           </a:p>
         </p:txBody>
       </p:sp>
@@ -273,10 +288,9 @@
           </a:lstStyle>
           <a:p>
             <a:r>
-              <a:rPr lang="en-US" smtClean="0"/>
+              <a:rPr lang="en-US"/>
               <a:t>Click to edit Master subtitle style</a:t>
             </a:r>
-            <a:endParaRPr lang="en-US"/>
           </a:p>
         </p:txBody>
       </p:sp>
@@ -297,7 +311,7 @@
           <a:p>
             <a:fld id="{5BCAD085-E8A6-8845-BD4E-CB4CCA059FC4}" type="datetimeFigureOut">
               <a:rPr lang="en-US" smtClean="0"/>
-              <a:t>1/27/13</a:t>
+              <a:t>10/13/2026</a:t>
             </a:fld>
             <a:endParaRPr lang="en-US"/>
           </a:p>
@@ -391,10 +405,9 @@
           <a:lstStyle/>
           <a:p>
             <a:r>
-              <a:rPr lang="en-US" smtClean="0"/>
+              <a:rPr lang="en-US"/>
               <a:t>Click to edit Master title style</a:t>
             </a:r>
-            <a:endParaRPr lang="en-US"/>
           </a:p>
         </p:txBody>
       </p:sp>
@@ -415,38 +428,37 @@
           <a:p>
             <a:pPr lvl="0"/>
             <a:r>
-              <a:rPr lang="en-US" smtClean="0"/>
+              <a:rPr lang="en-US"/>
               <a:t>Click to edit Master text styles</a:t>
             </a:r>
           </a:p>
           <a:p>
             <a:pPr lvl="1"/>
             <a:r>
-              <a:rPr lang="en-US" smtClean="0"/>
+              <a:rPr lang="en-US"/>
               <a:t>Second level</a:t>
             </a:r>
           </a:p>
           <a:p>
             <a:pPr lvl="2"/>
             <a:r>
-              <a:rPr lang="en-US" smtClean="0"/>
+              <a:rPr lang="en-US"/>
               <a:t>Third level</a:t>
             </a:r>
           </a:p>
           <a:p>
             <a:pPr lvl="3"/>
             <a:r>
-              <a:rPr lang="en-US" smtClean="0"/>
+              <a:rPr lang="en-US"/>
               <a:t>Fourth level</a:t>
             </a:r>
           </a:p>
           <a:p>
             <a:pPr lvl="4"/>
             <a:r>
-              <a:rPr lang="en-US" smtClean="0"/>
+              <a:rPr lang="en-US"/>
               <a:t>Fifth level</a:t>
             </a:r>
-            <a:endParaRPr lang="en-US"/>
           </a:p>
         </p:txBody>
       </p:sp>
@@ -467,7 +479,7 @@
           <a:p>
             <a:fld id="{5BCAD085-E8A6-8845-BD4E-CB4CCA059FC4}" type="datetimeFigureOut">
               <a:rPr lang="en-US" smtClean="0"/>
-              <a:t>1/27/13</a:t>
+              <a:t>10/13/2026</a:t>
             </a:fld>
             <a:endParaRPr lang="en-US"/>
           </a:p>
@@ -566,10 +578,9 @@
           <a:lstStyle/>
           <a:p>
             <a:r>
-              <a:rPr lang="en-US" smtClean="0"/>
+              <a:rPr lang="en-US"/>
               <a:t>Click to edit Master title style</a:t>
             </a:r>
-            <a:endParaRPr lang="en-US"/>
           </a:p>
         </p:txBody>
       </p:sp>
@@ -595,38 +606,37 @@
           <a:p>
             <a:pPr lvl="0"/>
             <a:r>
-              <a:rPr lang="en-US" smtClean="0"/>
+              <a:rPr lang="en-US"/>
               <a:t>Click to edit Master text styles</a:t>
             </a:r>
           </a:p>
           <a:p>
             <a:pPr lvl="1"/>
             <a:r>
-              <a:rPr lang="en-US" smtClean="0"/>
+              <a:rPr lang="en-US"/>
               <a:t>Second level</a:t>
             </a:r>
           </a:p>
           <a:p>
             <a:pPr lvl="2"/>
             <a:r>
-              <a:rPr lang="en-US" smtClean="0"/>
+              <a:rPr lang="en-US"/>
               <a:t>Third level</a:t>
             </a:r>
           </a:p>
           <a:p>
             <a:pPr lvl="3"/>
             <a:r>
-              <a:rPr lang="en-US" smtClean="0"/>
+              <a:rPr lang="en-US"/>
               <a:t>Fourth level</a:t>
             </a:r>
           </a:p>
           <a:p>
             <a:pPr lvl="4"/>
             <a:r>
-              <a:rPr lang="en-US" smtClean="0"/>
+              <a:rPr lang="en-US"/>
               <a:t>Fifth level</a:t>
             </a:r>
-            <a:endParaRPr lang="en-US"/>
           </a:p>
         </p:txBody>
       </p:sp>
@@ -647,7 +657,7 @@
           <a:p>
             <a:fld id="{5BCAD085-E8A6-8845-BD4E-CB4CCA059FC4}" type="datetimeFigureOut">
               <a:rPr lang="en-US" smtClean="0"/>
-              <a:t>1/27/13</a:t>
+              <a:t>10/13/2026</a:t>
             </a:fld>
             <a:endParaRPr lang="en-US"/>
           </a:p>
@@ -741,10 +751,9 @@
           <a:lstStyle/>
           <a:p>
             <a:r>
-              <a:rPr lang="en-US" smtClean="0"/>
+              <a:rPr lang="en-US"/>
               <a:t>Click to edit Master title style</a:t>
             </a:r>
-            <a:endParaRPr lang="en-US"/>
           </a:p>
         </p:txBody>
       </p:sp>
@@ -765,38 +774,37 @@
           <a:p>
             <a:pPr lvl="0"/>
             <a:r>
-              <a:rPr lang="en-US" smtClean="0"/>
+              <a:rPr lang="en-US"/>
               <a:t>Click to edit Master text styles</a:t>
             </a:r>
           </a:p>
           <a:p>
             <a:pPr lvl="1"/>
             <a:r>
-              <a:rPr lang="en-US" smtClean="0"/>
+              <a:rPr lang="en-US"/>
               <a:t>Second level</a:t>
             </a:r>
           </a:p>
           <a:p>
             <a:pPr lvl="2"/>
             <a:r>
-              <a:rPr lang="en-US" smtClean="0"/>
+              <a:rPr lang="en-US"/>
               <a:t>Third level</a:t>
             </a:r>
           </a:p>
           <a:p>
             <a:pPr lvl="3"/>
             <a:r>
-              <a:rPr lang="en-US" smtClean="0"/>
+              <a:rPr lang="en-US"/>
               <a:t>Fourth level</a:t>
             </a:r>
           </a:p>
           <a:p>
             <a:pPr lvl="4"/>
             <a:r>
-              <a:rPr lang="en-US" smtClean="0"/>
+              <a:rPr lang="en-US"/>
               <a:t>Fifth level</a:t>
             </a:r>
-            <a:endParaRPr lang="en-US"/>
           </a:p>
         </p:txBody>
       </p:sp>
@@ -817,7 +825,7 @@
           <a:p>
             <a:fld id="{5BCAD085-E8A6-8845-BD4E-CB4CCA059FC4}" type="datetimeFigureOut">
               <a:rPr lang="en-US" smtClean="0"/>
-              <a:t>1/27/13</a:t>
+              <a:t>10/13/2026</a:t>
             </a:fld>
             <a:endParaRPr lang="en-US"/>
           </a:p>
@@ -920,10 +928,9 @@
           </a:lstStyle>
           <a:p>
             <a:r>
-              <a:rPr lang="en-US" smtClean="0"/>
+              <a:rPr lang="en-US"/>
               <a:t>Click to edit Master title style</a:t>
             </a:r>
-            <a:endParaRPr lang="en-US"/>
           </a:p>
         </p:txBody>
       </p:sp>
@@ -1040,7 +1047,7 @@
           <a:p>
             <a:pPr lvl="0"/>
             <a:r>
-              <a:rPr lang="en-US" smtClean="0"/>
+              <a:rPr lang="en-US"/>
               <a:t>Click to edit Master text styles</a:t>
             </a:r>
           </a:p>
@@ -1063,7 +1070,7 @@
           <a:p>
             <a:fld id="{5BCAD085-E8A6-8845-BD4E-CB4CCA059FC4}" type="datetimeFigureOut">
               <a:rPr lang="en-US" smtClean="0"/>
-              <a:t>1/27/13</a:t>
+              <a:t>10/13/2026</a:t>
             </a:fld>
             <a:endParaRPr lang="en-US"/>
           </a:p>
@@ -1157,10 +1164,9 @@
           <a:lstStyle/>
           <a:p>
             <a:r>
-              <a:rPr lang="en-US" smtClean="0"/>
+              <a:rPr lang="en-US"/>
               <a:t>Click to edit Master title style</a:t>
             </a:r>
-            <a:endParaRPr lang="en-US"/>
           </a:p>
         </p:txBody>
       </p:sp>
@@ -1214,38 +1220,37 @@
           <a:p>
             <a:pPr lvl="0"/>
             <a:r>
-              <a:rPr lang="en-US" smtClean="0"/>
+              <a:rPr lang="en-US"/>
               <a:t>Click to edit Master text styles</a:t>
             </a:r>
           </a:p>
           <a:p>
             <a:pPr lvl="1"/>
             <a:r>
-              <a:rPr lang="en-US" smtClean="0"/>
+              <a:rPr lang="en-US"/>
               <a:t>Second level</a:t>
             </a:r>
           </a:p>
           <a:p>
             <a:pPr lvl="2"/>
             <a:r>
-              <a:rPr lang="en-US" smtClean="0"/>
+              <a:rPr lang="en-US"/>
               <a:t>Third level</a:t>
             </a:r>
           </a:p>
           <a:p>
             <a:pPr lvl="3"/>
             <a:r>
-              <a:rPr lang="en-US" smtClean="0"/>
+              <a:rPr lang="en-US"/>
               <a:t>Fourth level</a:t>
             </a:r>
           </a:p>
           <a:p>
             <a:pPr lvl="4"/>
             <a:r>
-              <a:rPr lang="en-US" smtClean="0"/>
+              <a:rPr lang="en-US"/>
               <a:t>Fifth level</a:t>
             </a:r>
-            <a:endParaRPr lang="en-US"/>
           </a:p>
         </p:txBody>
       </p:sp>
@@ -1299,38 +1304,37 @@
           <a:p>
             <a:pPr lvl="0"/>
             <a:r>
-              <a:rPr lang="en-US" smtClean="0"/>
+              <a:rPr lang="en-US"/>
               <a:t>Click to edit Master text styles</a:t>
             </a:r>
           </a:p>
           <a:p>
             <a:pPr lvl="1"/>
             <a:r>
-              <a:rPr lang="en-US" smtClean="0"/>
+              <a:rPr lang="en-US"/>
               <a:t>Second level</a:t>
             </a:r>
           </a:p>
           <a:p>
             <a:pPr lvl="2"/>
             <a:r>
-              <a:rPr lang="en-US" smtClean="0"/>
+              <a:rPr lang="en-US"/>
               <a:t>Third level</a:t>
             </a:r>
           </a:p>
           <a:p>
             <a:pPr lvl="3"/>
             <a:r>
-              <a:rPr lang="en-US" smtClean="0"/>
+              <a:rPr lang="en-US"/>
               <a:t>Fourth level</a:t>
             </a:r>
           </a:p>
           <a:p>
             <a:pPr lvl="4"/>
             <a:r>
-              <a:rPr lang="en-US" smtClean="0"/>
+              <a:rPr lang="en-US"/>
               <a:t>Fifth level</a:t>
             </a:r>
-            <a:endParaRPr lang="en-US"/>
           </a:p>
         </p:txBody>
       </p:sp>
@@ -1351,7 +1355,7 @@
           <a:p>
             <a:fld id="{5BCAD085-E8A6-8845-BD4E-CB4CCA059FC4}" type="datetimeFigureOut">
               <a:rPr lang="en-US" smtClean="0"/>
-              <a:t>1/27/13</a:t>
+              <a:t>10/13/2026</a:t>
             </a:fld>
             <a:endParaRPr lang="en-US"/>
           </a:p>
@@ -1449,10 +1453,9 @@
           </a:lstStyle>
           <a:p>
             <a:r>
-              <a:rPr lang="en-US" smtClean="0"/>
+              <a:rPr lang="en-US"/>
               <a:t>Click to edit Master title style</a:t>
             </a:r>
-            <a:endParaRPr lang="en-US"/>
           </a:p>
         </p:txBody>
       </p:sp>
@@ -1515,7 +1518,7 @@
           <a:p>
             <a:pPr lvl="0"/>
             <a:r>
-              <a:rPr lang="en-US" smtClean="0"/>
+              <a:rPr lang="en-US"/>
               <a:t>Click to edit Master text styles</a:t>
             </a:r>
           </a:p>
@@ -1571,38 +1574,37 @@
           <a:p>
             <a:pPr lvl="0"/>
             <a:r>
-              <a:rPr lang="en-US" smtClean="0"/>
+              <a:rPr lang="en-US"/>
               <a:t>Click to edit Master text styles</a:t>
             </a:r>
           </a:p>
           <a:p>
             <a:pPr lvl="1"/>
             <a:r>
-              <a:rPr lang="en-US" smtClean="0"/>
+              <a:rPr lang="en-US"/>
               <a:t>Second level</a:t>
             </a:r>
           </a:p>
           <a:p>
             <a:pPr lvl="2"/>
             <a:r>
-              <a:rPr lang="en-US" smtClean="0"/>
+              <a:rPr lang="en-US"/>
               <a:t>Third level</a:t>
             </a:r>
           </a:p>
           <a:p>
             <a:pPr lvl="3"/>
             <a:r>
-              <a:rPr lang="en-US" smtClean="0"/>
+              <a:rPr lang="en-US"/>
               <a:t>Fourth level</a:t>
             </a:r>
           </a:p>
           <a:p>
             <a:pPr lvl="4"/>
             <a:r>
-              <a:rPr lang="en-US" smtClean="0"/>
+              <a:rPr lang="en-US"/>
               <a:t>Fifth level</a:t>
             </a:r>
-            <a:endParaRPr lang="en-US"/>
           </a:p>
         </p:txBody>
       </p:sp>
@@ -1665,7 +1667,7 @@
           <a:p>
             <a:pPr lvl="0"/>
             <a:r>
-              <a:rPr lang="en-US" smtClean="0"/>
+              <a:rPr lang="en-US"/>
               <a:t>Click to edit Master text styles</a:t>
             </a:r>
           </a:p>
@@ -1721,38 +1723,37 @@
           <a:p>
             <a:pPr lvl="0"/>
             <a:r>
-              <a:rPr lang="en-US" smtClean="0"/>
+              <a:rPr lang="en-US"/>
               <a:t>Click to edit Master text styles</a:t>
             </a:r>
           </a:p>
           <a:p>
             <a:pPr lvl="1"/>
             <a:r>
-              <a:rPr lang="en-US" smtClean="0"/>
+              <a:rPr lang="en-US"/>
               <a:t>Second level</a:t>
             </a:r>
           </a:p>
           <a:p>
             <a:pPr lvl="2"/>
             <a:r>
-              <a:rPr lang="en-US" smtClean="0"/>
+              <a:rPr lang="en-US"/>
               <a:t>Third level</a:t>
             </a:r>
           </a:p>
           <a:p>
             <a:pPr lvl="3"/>
             <a:r>
-              <a:rPr lang="en-US" smtClean="0"/>
+              <a:rPr lang="en-US"/>
               <a:t>Fourth level</a:t>
             </a:r>
           </a:p>
           <a:p>
             <a:pPr lvl="4"/>
             <a:r>
-              <a:rPr lang="en-US" smtClean="0"/>
+              <a:rPr lang="en-US"/>
               <a:t>Fifth level</a:t>
             </a:r>
-            <a:endParaRPr lang="en-US"/>
           </a:p>
         </p:txBody>
       </p:sp>
@@ -1773,7 +1774,7 @@
           <a:p>
             <a:fld id="{5BCAD085-E8A6-8845-BD4E-CB4CCA059FC4}" type="datetimeFigureOut">
               <a:rPr lang="en-US" smtClean="0"/>
-              <a:t>1/27/13</a:t>
+              <a:t>10/13/2026</a:t>
             </a:fld>
             <a:endParaRPr lang="en-US"/>
           </a:p>
@@ -1867,10 +1868,9 @@
           <a:lstStyle/>
           <a:p>
             <a:r>
-              <a:rPr lang="en-US" smtClean="0"/>
+              <a:rPr lang="en-US"/>
               <a:t>Click to edit Master title style</a:t>
             </a:r>
-            <a:endParaRPr lang="en-US"/>
           </a:p>
         </p:txBody>
       </p:sp>
@@ -1891,7 +1891,7 @@
           <a:p>
             <a:fld id="{5BCAD085-E8A6-8845-BD4E-CB4CCA059FC4}" type="datetimeFigureOut">
               <a:rPr lang="en-US" smtClean="0"/>
-              <a:t>1/27/13</a:t>
+              <a:t>10/13/2026</a:t>
             </a:fld>
             <a:endParaRPr lang="en-US"/>
           </a:p>
@@ -1986,7 +1986,7 @@
           <a:p>
             <a:fld id="{5BCAD085-E8A6-8845-BD4E-CB4CCA059FC4}" type="datetimeFigureOut">
               <a:rPr lang="en-US" smtClean="0"/>
-              <a:t>1/27/13</a:t>
+              <a:t>10/13/2026</a:t>
             </a:fld>
             <a:endParaRPr lang="en-US"/>
           </a:p>
@@ -2089,10 +2089,9 @@
           </a:lstStyle>
           <a:p>
             <a:r>
-              <a:rPr lang="en-US" smtClean="0"/>
+              <a:rPr lang="en-US"/>
               <a:t>Click to edit Master title style</a:t>
             </a:r>
-            <a:endParaRPr lang="en-US"/>
           </a:p>
         </p:txBody>
       </p:sp>
@@ -2146,38 +2145,37 @@
           <a:p>
             <a:pPr lvl="0"/>
             <a:r>
-              <a:rPr lang="en-US" smtClean="0"/>
+              <a:rPr lang="en-US"/>
               <a:t>Click to edit Master text styles</a:t>
             </a:r>
           </a:p>
           <a:p>
             <a:pPr lvl="1"/>
             <a:r>
-              <a:rPr lang="en-US" smtClean="0"/>
+              <a:rPr lang="en-US"/>
               <a:t>Second level</a:t>
             </a:r>
           </a:p>
           <a:p>
             <a:pPr lvl="2"/>
             <a:r>
-              <a:rPr lang="en-US" smtClean="0"/>
+              <a:rPr lang="en-US"/>
               <a:t>Third level</a:t>
             </a:r>
           </a:p>
           <a:p>
             <a:pPr lvl="3"/>
             <a:r>
-              <a:rPr lang="en-US" smtClean="0"/>
+              <a:rPr lang="en-US"/>
               <a:t>Fourth level</a:t>
             </a:r>
           </a:p>
           <a:p>
             <a:pPr lvl="4"/>
             <a:r>
-              <a:rPr lang="en-US" smtClean="0"/>
+              <a:rPr lang="en-US"/>
               <a:t>Fifth level</a:t>
             </a:r>
-            <a:endParaRPr lang="en-US"/>
           </a:p>
         </p:txBody>
       </p:sp>
@@ -2240,7 +2238,7 @@
           <a:p>
             <a:pPr lvl="0"/>
             <a:r>
-              <a:rPr lang="en-US" smtClean="0"/>
+              <a:rPr lang="en-US"/>
               <a:t>Click to edit Master text styles</a:t>
             </a:r>
           </a:p>
@@ -2263,7 +2261,7 @@
           <a:p>
             <a:fld id="{5BCAD085-E8A6-8845-BD4E-CB4CCA059FC4}" type="datetimeFigureOut">
               <a:rPr lang="en-US" smtClean="0"/>
-              <a:t>1/27/13</a:t>
+              <a:t>10/13/2026</a:t>
             </a:fld>
             <a:endParaRPr lang="en-US"/>
           </a:p>
@@ -2366,10 +2364,9 @@
           </a:lstStyle>
           <a:p>
             <a:r>
-              <a:rPr lang="en-US" smtClean="0"/>
+              <a:rPr lang="en-US"/>
               <a:t>Click to edit Master title style</a:t>
             </a:r>
-            <a:endParaRPr lang="en-US"/>
           </a:p>
         </p:txBody>
       </p:sp>
@@ -2493,7 +2490,7 @@
           <a:p>
             <a:pPr lvl="0"/>
             <a:r>
-              <a:rPr lang="en-US" smtClean="0"/>
+              <a:rPr lang="en-US"/>
               <a:t>Click to edit Master text styles</a:t>
             </a:r>
           </a:p>
@@ -2516,7 +2513,7 @@
           <a:p>
             <a:fld id="{5BCAD085-E8A6-8845-BD4E-CB4CCA059FC4}" type="datetimeFigureOut">
               <a:rPr lang="en-US" smtClean="0"/>
-              <a:t>1/27/13</a:t>
+              <a:t>10/13/2026</a:t>
             </a:fld>
             <a:endParaRPr lang="en-US"/>
           </a:p>
@@ -2625,10 +2622,9 @@
           <a:lstStyle/>
           <a:p>
             <a:r>
-              <a:rPr lang="en-US" smtClean="0"/>
+              <a:rPr lang="en-US"/>
               <a:t>Click to edit Master title style</a:t>
             </a:r>
-            <a:endParaRPr lang="en-US"/>
           </a:p>
         </p:txBody>
       </p:sp>
@@ -2659,38 +2655,37 @@
           <a:p>
             <a:pPr lvl="0"/>
             <a:r>
-              <a:rPr lang="en-US" smtClean="0"/>
+              <a:rPr lang="en-US"/>
               <a:t>Click to edit Master text styles</a:t>
             </a:r>
           </a:p>
           <a:p>
             <a:pPr lvl="1"/>
             <a:r>
-              <a:rPr lang="en-US" smtClean="0"/>
+              <a:rPr lang="en-US"/>
               <a:t>Second level</a:t>
             </a:r>
           </a:p>
           <a:p>
             <a:pPr lvl="2"/>
             <a:r>
-              <a:rPr lang="en-US" smtClean="0"/>
+              <a:rPr lang="en-US"/>
               <a:t>Third level</a:t>
             </a:r>
           </a:p>
           <a:p>
             <a:pPr lvl="3"/>
             <a:r>
-              <a:rPr lang="en-US" smtClean="0"/>
+              <a:rPr lang="en-US"/>
               <a:t>Fourth level</a:t>
             </a:r>
           </a:p>
           <a:p>
             <a:pPr lvl="4"/>
             <a:r>
-              <a:rPr lang="en-US" smtClean="0"/>
+              <a:rPr lang="en-US"/>
               <a:t>Fifth level</a:t>
             </a:r>
-            <a:endParaRPr lang="en-US"/>
           </a:p>
         </p:txBody>
       </p:sp>
@@ -2729,7 +2724,7 @@
           <a:p>
             <a:fld id="{5BCAD085-E8A6-8845-BD4E-CB4CCA059FC4}" type="datetimeFigureOut">
               <a:rPr lang="en-US" smtClean="0"/>
-              <a:t>1/27/13</a:t>
+              <a:t>10/13/2026</a:t>
             </a:fld>
             <a:endParaRPr lang="en-US"/>
           </a:p>
@@ -3088,7 +3083,7 @@
 </file>
 
 <file path=ppt/slides/slide1.xml><?xml version="1.0" encoding="utf-8"?>
-<p:sld xmlns:a="http://schemas.openxmlformats.org/drawingml/2006/main" xmlns:p="http://schemas.openxmlformats.org/presentationml/2006/main" xmlns:r="http://schemas.openxmlformats.org/officeDocument/2006/relationships">
+<p:sld xmlns:a="http://schemas.openxmlformats.org/drawingml/2006/main" xmlns:r="http://schemas.openxmlformats.org/officeDocument/2006/relationships" xmlns:p="http://schemas.openxmlformats.org/presentationml/2006/main">
   <p:cSld>
     <p:spTree>
       <p:nvGrpSpPr>
@@ -3096,7 +3091,14 @@
         <p:cNvGrpSpPr/>
         <p:nvPr/>
       </p:nvGrpSpPr>
-      <p:grpSpPr/>
+      <p:grpSpPr>
+        <a:xfrm>
+          <a:off x="0" y="0"/>
+          <a:ext cx="0" cy="0"/>
+          <a:chOff x="0" y="0"/>
+          <a:chExt cx="0" cy="0"/>
+        </a:xfrm>
+      </p:grpSpPr>
       <p:sp>
         <p:nvSpPr>
           <p:cNvPr id="2" name="Rectangle 1"/>
@@ -3137,6 +3139,7 @@
           <a:lstStyle/>
           <a:p>
             <a:pPr algn="ctr"/>
+            <a:endParaRPr/>
           </a:p>
         </p:txBody>
       </p:sp>
@@ -3266,7 +3269,7 @@
 </file>
 
 <file path=ppt/slides/slide10.xml><?xml version="1.0" encoding="utf-8"?>
-<p:sld xmlns:a="http://schemas.openxmlformats.org/drawingml/2006/main" xmlns:p="http://schemas.openxmlformats.org/presentationml/2006/main" xmlns:r="http://schemas.openxmlformats.org/officeDocument/2006/relationships">
+<p:sld xmlns:a="http://schemas.openxmlformats.org/drawingml/2006/main" xmlns:r="http://schemas.openxmlformats.org/officeDocument/2006/relationships" xmlns:p="http://schemas.openxmlformats.org/presentationml/2006/main">
   <p:cSld>
     <p:spTree>
       <p:nvGrpSpPr>
@@ -3274,7 +3277,14 @@
         <p:cNvGrpSpPr/>
         <p:nvPr/>
       </p:nvGrpSpPr>
-      <p:grpSpPr/>
+      <p:grpSpPr>
+        <a:xfrm>
+          <a:off x="0" y="0"/>
+          <a:ext cx="0" cy="0"/>
+          <a:chOff x="0" y="0"/>
+          <a:chExt cx="0" cy="0"/>
+        </a:xfrm>
+      </p:grpSpPr>
       <p:sp>
         <p:nvSpPr>
           <p:cNvPr id="2" name="Rectangle 1"/>
@@ -3315,6 +3325,7 @@
           <a:lstStyle/>
           <a:p>
             <a:pPr algn="ctr"/>
+            <a:endParaRPr/>
           </a:p>
         </p:txBody>
       </p:sp>
@@ -3601,7 +3612,7 @@
 </file>
 
 <file path=ppt/slides/slide2.xml><?xml version="1.0" encoding="utf-8"?>
-<p:sld xmlns:a="http://schemas.openxmlformats.org/drawingml/2006/main" xmlns:p="http://schemas.openxmlformats.org/presentationml/2006/main" xmlns:r="http://schemas.openxmlformats.org/officeDocument/2006/relationships">
+<p:sld xmlns:a="http://schemas.openxmlformats.org/drawingml/2006/main" xmlns:r="http://schemas.openxmlformats.org/officeDocument/2006/relationships" xmlns:p="http://schemas.openxmlformats.org/presentationml/2006/main">
   <p:cSld>
     <p:spTree>
       <p:nvGrpSpPr>
@@ -3609,7 +3620,14 @@
         <p:cNvGrpSpPr/>
         <p:nvPr/>
       </p:nvGrpSpPr>
-      <p:grpSpPr/>
+      <p:grpSpPr>
+        <a:xfrm>
+          <a:off x="0" y="0"/>
+          <a:ext cx="0" cy="0"/>
+          <a:chOff x="0" y="0"/>
+          <a:chExt cx="0" cy="0"/>
+        </a:xfrm>
+      </p:grpSpPr>
       <p:sp>
         <p:nvSpPr>
           <p:cNvPr id="2" name="Rectangle 1"/>
@@ -3650,6 +3668,7 @@
           <a:lstStyle/>
           <a:p>
             <a:pPr algn="ctr"/>
+            <a:endParaRPr/>
           </a:p>
         </p:txBody>
       </p:sp>
@@ -3919,6 +3938,7 @@
           <a:lstStyle/>
           <a:p>
             <a:pPr algn="ctr"/>
+            <a:endParaRPr/>
           </a:p>
         </p:txBody>
       </p:sp>
@@ -3986,7 +4006,7 @@
 </file>
 
 <file path=ppt/slides/slide3.xml><?xml version="1.0" encoding="utf-8"?>
-<p:sld xmlns:a="http://schemas.openxmlformats.org/drawingml/2006/main" xmlns:p="http://schemas.openxmlformats.org/presentationml/2006/main" xmlns:r="http://schemas.openxmlformats.org/officeDocument/2006/relationships">
+<p:sld xmlns:a="http://schemas.openxmlformats.org/drawingml/2006/main" xmlns:r="http://schemas.openxmlformats.org/officeDocument/2006/relationships" xmlns:p="http://schemas.openxmlformats.org/presentationml/2006/main">
   <p:cSld>
     <p:spTree>
       <p:nvGrpSpPr>
@@ -3994,7 +4014,14 @@
         <p:cNvGrpSpPr/>
         <p:nvPr/>
       </p:nvGrpSpPr>
-      <p:grpSpPr/>
+      <p:grpSpPr>
+        <a:xfrm>
+          <a:off x="0" y="0"/>
+          <a:ext cx="0" cy="0"/>
+          <a:chOff x="0" y="0"/>
+          <a:chExt cx="0" cy="0"/>
+        </a:xfrm>
+      </p:grpSpPr>
       <p:sp>
         <p:nvSpPr>
           <p:cNvPr id="2" name="Rectangle 1"/>
@@ -4035,6 +4062,7 @@
           <a:lstStyle/>
           <a:p>
             <a:pPr algn="ctr"/>
+            <a:endParaRPr/>
           </a:p>
         </p:txBody>
       </p:sp>
@@ -4156,6 +4184,7 @@
           <a:lstStyle/>
           <a:p>
             <a:pPr algn="ctr"/>
+            <a:endParaRPr/>
           </a:p>
         </p:txBody>
       </p:sp>
@@ -4316,6 +4345,7 @@
           <a:lstStyle/>
           <a:p>
             <a:pPr algn="ctr"/>
+            <a:endParaRPr/>
           </a:p>
         </p:txBody>
       </p:sp>
@@ -4476,6 +4506,7 @@
           <a:lstStyle/>
           <a:p>
             <a:pPr algn="ctr"/>
+            <a:endParaRPr/>
           </a:p>
         </p:txBody>
       </p:sp>
@@ -4636,6 +4667,7 @@
           <a:lstStyle/>
           <a:p>
             <a:pPr algn="ctr"/>
+            <a:endParaRPr/>
           </a:p>
         </p:txBody>
       </p:sp>
@@ -4796,6 +4828,7 @@
           <a:lstStyle/>
           <a:p>
             <a:pPr algn="ctr"/>
+            <a:endParaRPr/>
           </a:p>
         </p:txBody>
       </p:sp>
@@ -4956,6 +4989,7 @@
           <a:lstStyle/>
           <a:p>
             <a:pPr algn="ctr"/>
+            <a:endParaRPr/>
           </a:p>
         </p:txBody>
       </p:sp>
@@ -5124,7 +5158,7 @@
 </file>
 
 <file path=ppt/slides/slide4.xml><?xml version="1.0" encoding="utf-8"?>
-<p:sld xmlns:a="http://schemas.openxmlformats.org/drawingml/2006/main" xmlns:p="http://schemas.openxmlformats.org/presentationml/2006/main" xmlns:r="http://schemas.openxmlformats.org/officeDocument/2006/relationships">
+<p:sld xmlns:a="http://schemas.openxmlformats.org/drawingml/2006/main" xmlns:r="http://schemas.openxmlformats.org/officeDocument/2006/relationships" xmlns:p="http://schemas.openxmlformats.org/presentationml/2006/main">
   <p:cSld>
     <p:spTree>
       <p:nvGrpSpPr>
@@ -5132,7 +5166,14 @@
         <p:cNvGrpSpPr/>
         <p:nvPr/>
       </p:nvGrpSpPr>
-      <p:grpSpPr/>
+      <p:grpSpPr>
+        <a:xfrm>
+          <a:off x="0" y="0"/>
+          <a:ext cx="0" cy="0"/>
+          <a:chOff x="0" y="0"/>
+          <a:chExt cx="0" cy="0"/>
+        </a:xfrm>
+      </p:grpSpPr>
       <p:sp>
         <p:nvSpPr>
           <p:cNvPr id="2" name="Rectangle 1"/>
@@ -5173,6 +5214,7 @@
           <a:lstStyle/>
           <a:p>
             <a:pPr algn="ctr"/>
+            <a:endParaRPr/>
           </a:p>
         </p:txBody>
       </p:sp>
@@ -5264,7 +5306,7 @@
         </p:nvGraphicFramePr>
         <p:xfrm>
           <a:off x="640080" y="1737360"/>
-          <a:ext cx="10881360" cy="4242816"/>
+          <a:ext cx="10881360" cy="4261104"/>
         </p:xfrm>
         <a:graphic>
           <a:graphicData uri="http://schemas.openxmlformats.org/drawingml/2006/table">
@@ -5273,9 +5315,27 @@
                 <a:tableStyleId>{5C22544A-7EE6-4342-B048-85BDC9FD1C3A}</a:tableStyleId>
               </a:tblPr>
               <a:tblGrid>
-                <a:gridCol w="3383280"/>
-                <a:gridCol w="2743200"/>
-                <a:gridCol w="4754880"/>
+                <a:gridCol w="3383280">
+                  <a:extLst>
+                    <a:ext uri="{9D8B030D-6E8A-4147-A177-3AD203B41FA5}">
+                      <a16:colId xmlns:a16="http://schemas.microsoft.com/office/drawing/2014/main" val="20000"/>
+                    </a:ext>
+                  </a:extLst>
+                </a:gridCol>
+                <a:gridCol w="2743200">
+                  <a:extLst>
+                    <a:ext uri="{9D8B030D-6E8A-4147-A177-3AD203B41FA5}">
+                      <a16:colId xmlns:a16="http://schemas.microsoft.com/office/drawing/2014/main" val="20001"/>
+                    </a:ext>
+                  </a:extLst>
+                </a:gridCol>
+                <a:gridCol w="4754880">
+                  <a:extLst>
+                    <a:ext uri="{9D8B030D-6E8A-4147-A177-3AD203B41FA5}">
+                      <a16:colId xmlns:a16="http://schemas.microsoft.com/office/drawing/2014/main" val="20002"/>
+                    </a:ext>
+                  </a:extLst>
+                </a:gridCol>
               </a:tblGrid>
               <a:tr h="530352">
                 <a:tc>
@@ -5344,6 +5404,11 @@
                     </a:solidFill>
                   </a:tcPr>
                 </a:tc>
+                <a:extLst>
+                  <a:ext uri="{0D108BD9-81ED-4DB2-BD59-A6C34878D82A}">
+                    <a16:rowId xmlns:a16="http://schemas.microsoft.com/office/drawing/2014/main" val="10000"/>
+                  </a:ext>
+                </a:extLst>
               </a:tr>
               <a:tr h="530352">
                 <a:tc>
@@ -5412,6 +5477,11 @@
                     </a:solidFill>
                   </a:tcPr>
                 </a:tc>
+                <a:extLst>
+                  <a:ext uri="{0D108BD9-81ED-4DB2-BD59-A6C34878D82A}">
+                    <a16:rowId xmlns:a16="http://schemas.microsoft.com/office/drawing/2014/main" val="10001"/>
+                  </a:ext>
+                </a:extLst>
               </a:tr>
               <a:tr h="530352">
                 <a:tc>
@@ -5480,6 +5550,11 @@
                     </a:solidFill>
                   </a:tcPr>
                 </a:tc>
+                <a:extLst>
+                  <a:ext uri="{0D108BD9-81ED-4DB2-BD59-A6C34878D82A}">
+                    <a16:rowId xmlns:a16="http://schemas.microsoft.com/office/drawing/2014/main" val="10002"/>
+                  </a:ext>
+                </a:extLst>
               </a:tr>
               <a:tr h="530352">
                 <a:tc>
@@ -5548,6 +5623,11 @@
                     </a:solidFill>
                   </a:tcPr>
                 </a:tc>
+                <a:extLst>
+                  <a:ext uri="{0D108BD9-81ED-4DB2-BD59-A6C34878D82A}">
+                    <a16:rowId xmlns:a16="http://schemas.microsoft.com/office/drawing/2014/main" val="10003"/>
+                  </a:ext>
+                </a:extLst>
               </a:tr>
               <a:tr h="530352">
                 <a:tc>
@@ -5616,6 +5696,11 @@
                     </a:solidFill>
                   </a:tcPr>
                 </a:tc>
+                <a:extLst>
+                  <a:ext uri="{0D108BD9-81ED-4DB2-BD59-A6C34878D82A}">
+                    <a16:rowId xmlns:a16="http://schemas.microsoft.com/office/drawing/2014/main" val="10004"/>
+                  </a:ext>
+                </a:extLst>
               </a:tr>
               <a:tr h="530352">
                 <a:tc>
@@ -5684,6 +5769,11 @@
                     </a:solidFill>
                   </a:tcPr>
                 </a:tc>
+                <a:extLst>
+                  <a:ext uri="{0D108BD9-81ED-4DB2-BD59-A6C34878D82A}">
+                    <a16:rowId xmlns:a16="http://schemas.microsoft.com/office/drawing/2014/main" val="10005"/>
+                  </a:ext>
+                </a:extLst>
               </a:tr>
               <a:tr h="530352">
                 <a:tc>
@@ -5752,6 +5842,11 @@
                     </a:solidFill>
                   </a:tcPr>
                 </a:tc>
+                <a:extLst>
+                  <a:ext uri="{0D108BD9-81ED-4DB2-BD59-A6C34878D82A}">
+                    <a16:rowId xmlns:a16="http://schemas.microsoft.com/office/drawing/2014/main" val="10006"/>
+                  </a:ext>
+                </a:extLst>
               </a:tr>
               <a:tr h="530352">
                 <a:tc>
@@ -5820,6 +5915,11 @@
                     </a:solidFill>
                   </a:tcPr>
                 </a:tc>
+                <a:extLst>
+                  <a:ext uri="{0D108BD9-81ED-4DB2-BD59-A6C34878D82A}">
+                    <a16:rowId xmlns:a16="http://schemas.microsoft.com/office/drawing/2014/main" val="10007"/>
+                  </a:ext>
+                </a:extLst>
               </a:tr>
             </a:tbl>
           </a:graphicData>
@@ -5834,7 +5934,7 @@
 </file>
 
 <file path=ppt/slides/slide5.xml><?xml version="1.0" encoding="utf-8"?>
-<p:sld xmlns:a="http://schemas.openxmlformats.org/drawingml/2006/main" xmlns:p="http://schemas.openxmlformats.org/presentationml/2006/main" xmlns:r="http://schemas.openxmlformats.org/officeDocument/2006/relationships">
+<p:sld xmlns:a="http://schemas.openxmlformats.org/drawingml/2006/main" xmlns:r="http://schemas.openxmlformats.org/officeDocument/2006/relationships" xmlns:p="http://schemas.openxmlformats.org/presentationml/2006/main">
   <p:cSld>
     <p:spTree>
       <p:nvGrpSpPr>
@@ -5842,7 +5942,14 @@
         <p:cNvGrpSpPr/>
         <p:nvPr/>
       </p:nvGrpSpPr>
-      <p:grpSpPr/>
+      <p:grpSpPr>
+        <a:xfrm>
+          <a:off x="0" y="0"/>
+          <a:ext cx="0" cy="0"/>
+          <a:chOff x="0" y="0"/>
+          <a:chExt cx="0" cy="0"/>
+        </a:xfrm>
+      </p:grpSpPr>
       <p:sp>
         <p:nvSpPr>
           <p:cNvPr id="2" name="Rectangle 1"/>
@@ -5883,6 +5990,7 @@
           <a:lstStyle/>
           <a:p>
             <a:pPr algn="ctr"/>
+            <a:endParaRPr/>
           </a:p>
         </p:txBody>
       </p:sp>
@@ -6089,20 +6197,114 @@
       </p:sp>
       <p:sp>
         <p:nvSpPr>
-          <p:cNvPr id="6" name="Rounded Rectangle 5"/>
+          <p:cNvPr id="7" name="TextBox 6"/>
+          <p:cNvSpPr txBox="1"/>
+          <p:nvPr/>
+        </p:nvSpPr>
+        <p:spPr>
+          <a:xfrm>
+            <a:off x="5760720" y="3566160"/>
+            <a:ext cx="5760720" cy="914400"/>
+          </a:xfrm>
+          <a:prstGeom prst="rect">
+            <a:avLst/>
+          </a:prstGeom>
+          <a:noFill/>
+        </p:spPr>
+        <p:txBody>
+          <a:bodyPr wrap="square" anchor="t">
+            <a:spAutoFit/>
+          </a:bodyPr>
+          <a:lstStyle/>
+          <a:p>
+            <a:pPr algn="ctr">
+              <a:spcAft>
+                <a:spcPts val="800"/>
+              </a:spcAft>
+            </a:pPr>
+            <a:r>
+              <a:rPr sz="1400" b="0">
+                <a:solidFill>
+                  <a:srgbClr val="667085"/>
+                </a:solidFill>
+                <a:latin typeface="Calibri"/>
+              </a:rPr>
+              <a:t>[screenshot placeholder: 04_policy_changed_no_code.jpg]</a:t>
+            </a:r>
+          </a:p>
+        </p:txBody>
+      </p:sp>
+      <p:pic>
+        <p:nvPicPr>
+          <p:cNvPr id="9" name="Picture 8">
+            <a:extLst>
+              <a:ext uri="{FF2B5EF4-FFF2-40B4-BE49-F238E27FC236}">
+                <a16:creationId xmlns:a16="http://schemas.microsoft.com/office/drawing/2014/main" id="{8A8CD39C-913A-43B7-A267-695130CA93E4}"/>
+              </a:ext>
+            </a:extLst>
+          </p:cNvPr>
+          <p:cNvPicPr>
+            <a:picLocks noChangeAspect="1"/>
+          </p:cNvPicPr>
+          <p:nvPr/>
+        </p:nvPicPr>
+        <p:blipFill>
+          <a:blip r:embed="rId2"/>
+          <a:stretch>
+            <a:fillRect/>
+          </a:stretch>
+        </p:blipFill>
+        <p:spPr>
+          <a:xfrm>
+            <a:off x="5486400" y="2042551"/>
+            <a:ext cx="6364190" cy="3778738"/>
+          </a:xfrm>
+          <a:prstGeom prst="rect">
+            <a:avLst/>
+          </a:prstGeom>
+        </p:spPr>
+      </p:pic>
+    </p:spTree>
+  </p:cSld>
+  <p:clrMapOvr>
+    <a:masterClrMapping/>
+  </p:clrMapOvr>
+</p:sld>
+</file>
+
+<file path=ppt/slides/slide6.xml><?xml version="1.0" encoding="utf-8"?>
+<p:sld xmlns:a="http://schemas.openxmlformats.org/drawingml/2006/main" xmlns:r="http://schemas.openxmlformats.org/officeDocument/2006/relationships" xmlns:p="http://schemas.openxmlformats.org/presentationml/2006/main">
+  <p:cSld>
+    <p:spTree>
+      <p:nvGrpSpPr>
+        <p:cNvPr id="1" name=""/>
+        <p:cNvGrpSpPr/>
+        <p:nvPr/>
+      </p:nvGrpSpPr>
+      <p:grpSpPr>
+        <a:xfrm>
+          <a:off x="0" y="0"/>
+          <a:ext cx="0" cy="0"/>
+          <a:chOff x="0" y="0"/>
+          <a:chExt cx="0" cy="0"/>
+        </a:xfrm>
+      </p:grpSpPr>
+      <p:sp>
+        <p:nvSpPr>
+          <p:cNvPr id="2" name="Rectangle 1"/>
           <p:cNvSpPr/>
           <p:nvPr/>
         </p:nvSpPr>
         <p:spPr>
           <a:xfrm>
-            <a:off x="5486400" y="1645920"/>
-            <a:ext cx="6309360" cy="4572000"/>
-          </a:xfrm>
-          <a:prstGeom prst="roundRect">
+            <a:off x="0" y="0"/>
+            <a:ext cx="228600" cy="6858000"/>
+          </a:xfrm>
+          <a:prstGeom prst="rect">
             <a:avLst/>
           </a:prstGeom>
           <a:solidFill>
-            <a:srgbClr val="F2F4F7"/>
+            <a:srgbClr val="1D4ED8"/>
           </a:solidFill>
           <a:ln>
             <a:noFill/>
@@ -6127,19 +6329,98 @@
           <a:lstStyle/>
           <a:p>
             <a:pPr algn="ctr"/>
-          </a:p>
-        </p:txBody>
-      </p:sp>
-      <p:sp>
-        <p:nvSpPr>
-          <p:cNvPr id="7" name="TextBox 6"/>
+            <a:endParaRPr/>
+          </a:p>
+        </p:txBody>
+      </p:sp>
+      <p:sp>
+        <p:nvSpPr>
+          <p:cNvPr id="3" name="TextBox 2"/>
           <p:cNvSpPr txBox="1"/>
           <p:nvPr/>
         </p:nvSpPr>
         <p:spPr>
           <a:xfrm>
-            <a:off x="5760720" y="3566160"/>
-            <a:ext cx="5760720" cy="914400"/>
+            <a:off x="640080" y="365760"/>
+            <a:ext cx="10972800" cy="822960"/>
+          </a:xfrm>
+          <a:prstGeom prst="rect">
+            <a:avLst/>
+          </a:prstGeom>
+          <a:noFill/>
+        </p:spPr>
+        <p:txBody>
+          <a:bodyPr wrap="square" anchor="t">
+            <a:spAutoFit/>
+          </a:bodyPr>
+          <a:lstStyle/>
+          <a:p>
+            <a:pPr algn="l">
+              <a:spcAft>
+                <a:spcPts val="800"/>
+              </a:spcAft>
+            </a:pPr>
+            <a:r>
+              <a:rPr sz="3200" b="1">
+                <a:solidFill>
+                  <a:srgbClr val="1C2330"/>
+                </a:solidFill>
+                <a:latin typeface="Calibri"/>
+              </a:rPr>
+              <a:t>Every decision is explained</a:t>
+            </a:r>
+          </a:p>
+        </p:txBody>
+      </p:sp>
+      <p:sp>
+        <p:nvSpPr>
+          <p:cNvPr id="4" name="TextBox 3"/>
+          <p:cNvSpPr txBox="1"/>
+          <p:nvPr/>
+        </p:nvSpPr>
+        <p:spPr>
+          <a:xfrm>
+            <a:off x="640080" y="1051560"/>
+            <a:ext cx="10972800" cy="457200"/>
+          </a:xfrm>
+          <a:prstGeom prst="rect">
+            <a:avLst/>
+          </a:prstGeom>
+          <a:noFill/>
+        </p:spPr>
+        <p:txBody>
+          <a:bodyPr wrap="square" anchor="t">
+            <a:spAutoFit/>
+          </a:bodyPr>
+          <a:lstStyle/>
+          <a:p>
+            <a:pPr algn="l">
+              <a:spcAft>
+                <a:spcPts val="800"/>
+              </a:spcAft>
+            </a:pPr>
+            <a:r>
+              <a:rPr sz="1600" b="0">
+                <a:solidFill>
+                  <a:srgbClr val="667085"/>
+                </a:solidFill>
+                <a:latin typeface="Calibri"/>
+              </a:rPr>
+              <a:t>Category, clause, quote, arithmetic and what is still needed</a:t>
+            </a:r>
+          </a:p>
+        </p:txBody>
+      </p:sp>
+      <p:sp>
+        <p:nvSpPr>
+          <p:cNvPr id="6" name="TextBox 5"/>
+          <p:cNvSpPr txBox="1"/>
+          <p:nvPr/>
+        </p:nvSpPr>
+        <p:spPr>
+          <a:xfrm>
+            <a:off x="914400" y="3566160"/>
+            <a:ext cx="6400800" cy="914400"/>
           </a:xfrm>
           <a:prstGeom prst="rect">
             <a:avLst/>
@@ -6164,11 +6445,164 @@
                 </a:solidFill>
                 <a:latin typeface="Calibri"/>
               </a:rPr>
-              <a:t>[screenshot placeholder: 04_policy_changed_no_code.jpg]</a:t>
-            </a:r>
-          </a:p>
-        </p:txBody>
-      </p:sp>
+              <a:t>[screenshot placeholder: 02_explainable_decision.jpg]</a:t>
+            </a:r>
+          </a:p>
+        </p:txBody>
+      </p:sp>
+      <p:sp>
+        <p:nvSpPr>
+          <p:cNvPr id="7" name="TextBox 6"/>
+          <p:cNvSpPr txBox="1"/>
+          <p:nvPr/>
+        </p:nvSpPr>
+        <p:spPr>
+          <a:xfrm>
+            <a:off x="7863840" y="1737360"/>
+            <a:ext cx="4023360" cy="4389120"/>
+          </a:xfrm>
+          <a:prstGeom prst="rect">
+            <a:avLst/>
+          </a:prstGeom>
+          <a:noFill/>
+        </p:spPr>
+        <p:txBody>
+          <a:bodyPr wrap="square">
+            <a:spAutoFit/>
+          </a:bodyPr>
+          <a:lstStyle/>
+          <a:p>
+            <a:pPr>
+              <a:spcAft>
+                <a:spcPts val="1000"/>
+              </a:spcAft>
+            </a:pPr>
+            <a:r>
+              <a:rPr sz="1600" b="1">
+                <a:solidFill>
+                  <a:srgbClr val="1C2330"/>
+                </a:solidFill>
+                <a:latin typeface="Calibri"/>
+              </a:rPr>
+              <a:t>•  Why this category</a:t>
+            </a:r>
+            <a:r>
+              <a:rPr sz="1600">
+                <a:solidFill>
+                  <a:srgbClr val="667085"/>
+                </a:solidFill>
+                <a:latin typeface="Calibri"/>
+              </a:rPr>
+              <a:t> — the AI's reasoning</a:t>
+            </a:r>
+          </a:p>
+          <a:p>
+            <a:pPr>
+              <a:spcAft>
+                <a:spcPts val="1000"/>
+              </a:spcAft>
+            </a:pPr>
+            <a:r>
+              <a:rPr sz="1600" b="1">
+                <a:solidFill>
+                  <a:srgbClr val="1C2330"/>
+                </a:solidFill>
+                <a:latin typeface="Calibri"/>
+              </a:rPr>
+              <a:t>•  Which clause</a:t>
+            </a:r>
+            <a:r>
+              <a:rPr sz="1600">
+                <a:solidFill>
+                  <a:srgbClr val="667085"/>
+                </a:solidFill>
+                <a:latin typeface="Calibri"/>
+              </a:rPr>
+              <a:t> — TEP-2.1 and GE-2.2, with quotes</a:t>
+            </a:r>
+          </a:p>
+          <a:p>
+            <a:pPr>
+              <a:spcAft>
+                <a:spcPts val="1000"/>
+              </a:spcAft>
+            </a:pPr>
+            <a:r>
+              <a:rPr sz="1600" b="1">
+                <a:solidFill>
+                  <a:srgbClr val="1C2330"/>
+                </a:solidFill>
+                <a:latin typeface="Calibri"/>
+              </a:rPr>
+              <a:t>•  What is eligible</a:t>
+            </a:r>
+            <a:r>
+              <a:rPr sz="1600">
+                <a:solidFill>
+                  <a:srgbClr val="667085"/>
+                </a:solidFill>
+                <a:latin typeface="Calibri"/>
+              </a:rPr>
+              <a:t> — ₹5,000 of ₹7,168; excess not reimbursable</a:t>
+            </a:r>
+          </a:p>
+          <a:p>
+            <a:pPr>
+              <a:spcAft>
+                <a:spcPts val="1000"/>
+              </a:spcAft>
+            </a:pPr>
+            <a:r>
+              <a:rPr sz="1600" b="1">
+                <a:solidFill>
+                  <a:srgbClr val="1C2330"/>
+                </a:solidFill>
+                <a:latin typeface="Calibri"/>
+              </a:rPr>
+              <a:t>•  What is needed</a:t>
+            </a:r>
+            <a:r>
+              <a:rPr sz="1600">
+                <a:solidFill>
+                  <a:srgbClr val="667085"/>
+                </a:solidFill>
+                <a:latin typeface="Calibri"/>
+              </a:rPr>
+              <a:t> — shown as a question, once</a:t>
+            </a:r>
+          </a:p>
+        </p:txBody>
+      </p:sp>
+      <p:pic>
+        <p:nvPicPr>
+          <p:cNvPr id="9" name="Picture 8">
+            <a:extLst>
+              <a:ext uri="{FF2B5EF4-FFF2-40B4-BE49-F238E27FC236}">
+                <a16:creationId xmlns:a16="http://schemas.microsoft.com/office/drawing/2014/main" id="{45671753-DF15-EC41-1976-1638DA5923B8}"/>
+              </a:ext>
+            </a:extLst>
+          </p:cNvPr>
+          <p:cNvPicPr>
+            <a:picLocks noChangeAspect="1"/>
+          </p:cNvPicPr>
+          <p:nvPr/>
+        </p:nvPicPr>
+        <p:blipFill>
+          <a:blip r:embed="rId2"/>
+          <a:stretch>
+            <a:fillRect/>
+          </a:stretch>
+        </p:blipFill>
+        <p:spPr>
+          <a:xfrm>
+            <a:off x="969108" y="1773506"/>
+            <a:ext cx="6596184" cy="4122616"/>
+          </a:xfrm>
+          <a:prstGeom prst="rect">
+            <a:avLst/>
+          </a:prstGeom>
+        </p:spPr>
+      </p:pic>
     </p:spTree>
   </p:cSld>
   <p:clrMapOvr>
@@ -6177,8 +6611,8 @@
 </p:sld>
 </file>
 
-<file path=ppt/slides/slide6.xml><?xml version="1.0" encoding="utf-8"?>
-<p:sld xmlns:a="http://schemas.openxmlformats.org/drawingml/2006/main" xmlns:p="http://schemas.openxmlformats.org/presentationml/2006/main" xmlns:r="http://schemas.openxmlformats.org/officeDocument/2006/relationships">
+<file path=ppt/slides/slide7.xml><?xml version="1.0" encoding="utf-8"?>
+<p:sld xmlns:a="http://schemas.openxmlformats.org/drawingml/2006/main" xmlns:r="http://schemas.openxmlformats.org/officeDocument/2006/relationships" xmlns:p="http://schemas.openxmlformats.org/presentationml/2006/main">
   <p:cSld>
     <p:spTree>
       <p:nvGrpSpPr>
@@ -6186,7 +6620,14 @@
         <p:cNvGrpSpPr/>
         <p:nvPr/>
       </p:nvGrpSpPr>
-      <p:grpSpPr/>
+      <p:grpSpPr>
+        <a:xfrm>
+          <a:off x="0" y="0"/>
+          <a:ext cx="0" cy="0"/>
+          <a:chOff x="0" y="0"/>
+          <a:chExt cx="0" cy="0"/>
+        </a:xfrm>
+      </p:grpSpPr>
       <p:sp>
         <p:nvSpPr>
           <p:cNvPr id="2" name="Rectangle 1"/>
@@ -6227,6 +6668,7 @@
           <a:lstStyle/>
           <a:p>
             <a:pPr algn="ctr"/>
+            <a:endParaRPr/>
           </a:p>
         </p:txBody>
       </p:sp>
@@ -6264,7 +6706,7 @@
                 </a:solidFill>
                 <a:latin typeface="Calibri"/>
               </a:rPr>
-              <a:t>Every decision is explained</a:t>
+              <a:t>The experience</a:t>
             </a:r>
           </a:p>
         </p:txBody>
@@ -6303,27 +6745,190 @@
                 </a:solidFill>
                 <a:latin typeface="Calibri"/>
               </a:rPr>
-              <a:t>Category, clause, quote, arithmetic and what is still needed</a:t>
-            </a:r>
-          </a:p>
-        </p:txBody>
-      </p:sp>
-      <p:sp>
-        <p:nvSpPr>
-          <p:cNvPr id="5" name="Rounded Rectangle 4"/>
+              <a:t>Chat on the left, claim on the right</a:t>
+            </a:r>
+          </a:p>
+        </p:txBody>
+      </p:sp>
+      <p:sp>
+        <p:nvSpPr>
+          <p:cNvPr id="6" name="TextBox 5"/>
+          <p:cNvSpPr txBox="1"/>
+          <p:nvPr/>
+        </p:nvSpPr>
+        <p:spPr>
+          <a:xfrm>
+            <a:off x="731520" y="3383279"/>
+            <a:ext cx="5303520" cy="914400"/>
+          </a:xfrm>
+          <a:prstGeom prst="rect">
+            <a:avLst/>
+          </a:prstGeom>
+          <a:noFill/>
+        </p:spPr>
+        <p:txBody>
+          <a:bodyPr wrap="square" anchor="t">
+            <a:spAutoFit/>
+          </a:bodyPr>
+          <a:lstStyle/>
+          <a:p>
+            <a:pPr algn="ctr">
+              <a:spcAft>
+                <a:spcPts val="800"/>
+              </a:spcAft>
+            </a:pPr>
+            <a:r>
+              <a:rPr sz="1400" b="0">
+                <a:solidFill>
+                  <a:srgbClr val="667085"/>
+                </a:solidFill>
+                <a:latin typeface="Calibri"/>
+              </a:rPr>
+              <a:t>[screenshot placeholder: 01_claim_and_chat.jpg]</a:t>
+            </a:r>
+          </a:p>
+        </p:txBody>
+      </p:sp>
+      <p:sp>
+        <p:nvSpPr>
+          <p:cNvPr id="8" name="TextBox 7"/>
+          <p:cNvSpPr txBox="1"/>
+          <p:nvPr/>
+        </p:nvSpPr>
+        <p:spPr>
+          <a:xfrm>
+            <a:off x="6766559" y="3383279"/>
+            <a:ext cx="4754880" cy="914400"/>
+          </a:xfrm>
+          <a:prstGeom prst="rect">
+            <a:avLst/>
+          </a:prstGeom>
+          <a:noFill/>
+        </p:spPr>
+        <p:txBody>
+          <a:bodyPr wrap="square" anchor="t">
+            <a:spAutoFit/>
+          </a:bodyPr>
+          <a:lstStyle/>
+          <a:p>
+            <a:pPr algn="ctr">
+              <a:spcAft>
+                <a:spcPts val="800"/>
+              </a:spcAft>
+            </a:pPr>
+            <a:r>
+              <a:rPr sz="1400" b="0">
+                <a:solidFill>
+                  <a:srgbClr val="667085"/>
+                </a:solidFill>
+                <a:latin typeface="Calibri"/>
+              </a:rPr>
+              <a:t>[screenshot placeholder: 05_submitted.jpg]</a:t>
+            </a:r>
+          </a:p>
+        </p:txBody>
+      </p:sp>
+      <p:pic>
+        <p:nvPicPr>
+          <p:cNvPr id="10" name="Picture 9">
+            <a:extLst>
+              <a:ext uri="{FF2B5EF4-FFF2-40B4-BE49-F238E27FC236}">
+                <a16:creationId xmlns:a16="http://schemas.microsoft.com/office/drawing/2014/main" id="{DC041DD3-647C-EE69-6704-BF755E0C5C0A}"/>
+              </a:ext>
+            </a:extLst>
+          </p:cNvPr>
+          <p:cNvPicPr>
+            <a:picLocks noChangeAspect="1"/>
+          </p:cNvPicPr>
+          <p:nvPr/>
+        </p:nvPicPr>
+        <p:blipFill>
+          <a:blip r:embed="rId2"/>
+          <a:stretch>
+            <a:fillRect/>
+          </a:stretch>
+        </p:blipFill>
+        <p:spPr>
+          <a:xfrm>
+            <a:off x="306754" y="1758462"/>
+            <a:ext cx="5426724" cy="3313723"/>
+          </a:xfrm>
+          <a:prstGeom prst="rect">
+            <a:avLst/>
+          </a:prstGeom>
+        </p:spPr>
+      </p:pic>
+      <p:pic>
+        <p:nvPicPr>
+          <p:cNvPr id="12" name="Picture 11">
+            <a:extLst>
+              <a:ext uri="{FF2B5EF4-FFF2-40B4-BE49-F238E27FC236}">
+                <a16:creationId xmlns:a16="http://schemas.microsoft.com/office/drawing/2014/main" id="{6339CA6A-A8F0-5D4B-A7FA-32A3759971FD}"/>
+              </a:ext>
+            </a:extLst>
+          </p:cNvPr>
+          <p:cNvPicPr>
+            <a:picLocks noChangeAspect="1"/>
+          </p:cNvPicPr>
+          <p:nvPr/>
+        </p:nvPicPr>
+        <p:blipFill>
+          <a:blip r:embed="rId3"/>
+          <a:stretch>
+            <a:fillRect/>
+          </a:stretch>
+        </p:blipFill>
+        <p:spPr>
+          <a:xfrm>
+            <a:off x="5901027" y="1727786"/>
+            <a:ext cx="5830112" cy="3461629"/>
+          </a:xfrm>
+          <a:prstGeom prst="rect">
+            <a:avLst/>
+          </a:prstGeom>
+        </p:spPr>
+      </p:pic>
+    </p:spTree>
+  </p:cSld>
+  <p:clrMapOvr>
+    <a:masterClrMapping/>
+  </p:clrMapOvr>
+</p:sld>
+</file>
+
+<file path=ppt/slides/slide8.xml><?xml version="1.0" encoding="utf-8"?>
+<p:sld xmlns:a="http://schemas.openxmlformats.org/drawingml/2006/main" xmlns:r="http://schemas.openxmlformats.org/officeDocument/2006/relationships" xmlns:p="http://schemas.openxmlformats.org/presentationml/2006/main">
+  <p:cSld>
+    <p:spTree>
+      <p:nvGrpSpPr>
+        <p:cNvPr id="1" name=""/>
+        <p:cNvGrpSpPr/>
+        <p:nvPr/>
+      </p:nvGrpSpPr>
+      <p:grpSpPr>
+        <a:xfrm>
+          <a:off x="0" y="0"/>
+          <a:ext cx="0" cy="0"/>
+          <a:chOff x="0" y="0"/>
+          <a:chExt cx="0" cy="0"/>
+        </a:xfrm>
+      </p:grpSpPr>
+      <p:sp>
+        <p:nvSpPr>
+          <p:cNvPr id="2" name="Rectangle 1"/>
           <p:cNvSpPr/>
           <p:nvPr/>
         </p:nvSpPr>
         <p:spPr>
           <a:xfrm>
-            <a:off x="640080" y="1645920"/>
-            <a:ext cx="6949440" cy="4572000"/>
-          </a:xfrm>
-          <a:prstGeom prst="roundRect">
+            <a:off x="0" y="0"/>
+            <a:ext cx="228600" cy="6858000"/>
+          </a:xfrm>
+          <a:prstGeom prst="rect">
             <a:avLst/>
           </a:prstGeom>
           <a:solidFill>
-            <a:srgbClr val="F2F4F7"/>
+            <a:srgbClr val="1D4ED8"/>
           </a:solidFill>
           <a:ln>
             <a:noFill/>
@@ -6348,532 +6953,7 @@
           <a:lstStyle/>
           <a:p>
             <a:pPr algn="ctr"/>
-          </a:p>
-        </p:txBody>
-      </p:sp>
-      <p:sp>
-        <p:nvSpPr>
-          <p:cNvPr id="6" name="TextBox 5"/>
-          <p:cNvSpPr txBox="1"/>
-          <p:nvPr/>
-        </p:nvSpPr>
-        <p:spPr>
-          <a:xfrm>
-            <a:off x="914400" y="3566160"/>
-            <a:ext cx="6400800" cy="914400"/>
-          </a:xfrm>
-          <a:prstGeom prst="rect">
-            <a:avLst/>
-          </a:prstGeom>
-          <a:noFill/>
-        </p:spPr>
-        <p:txBody>
-          <a:bodyPr wrap="square" anchor="t">
-            <a:spAutoFit/>
-          </a:bodyPr>
-          <a:lstStyle/>
-          <a:p>
-            <a:pPr algn="ctr">
-              <a:spcAft>
-                <a:spcPts val="800"/>
-              </a:spcAft>
-            </a:pPr>
-            <a:r>
-              <a:rPr sz="1400" b="0">
-                <a:solidFill>
-                  <a:srgbClr val="667085"/>
-                </a:solidFill>
-                <a:latin typeface="Calibri"/>
-              </a:rPr>
-              <a:t>[screenshot placeholder: 02_explainable_decision.jpg]</a:t>
-            </a:r>
-          </a:p>
-        </p:txBody>
-      </p:sp>
-      <p:sp>
-        <p:nvSpPr>
-          <p:cNvPr id="7" name="TextBox 6"/>
-          <p:cNvSpPr txBox="1"/>
-          <p:nvPr/>
-        </p:nvSpPr>
-        <p:spPr>
-          <a:xfrm>
-            <a:off x="7863840" y="1737360"/>
-            <a:ext cx="4023360" cy="4389120"/>
-          </a:xfrm>
-          <a:prstGeom prst="rect">
-            <a:avLst/>
-          </a:prstGeom>
-          <a:noFill/>
-        </p:spPr>
-        <p:txBody>
-          <a:bodyPr wrap="square">
-            <a:spAutoFit/>
-          </a:bodyPr>
-          <a:lstStyle/>
-          <a:p>
-            <a:pPr>
-              <a:spcAft>
-                <a:spcPts val="1000"/>
-              </a:spcAft>
-            </a:pPr>
-            <a:r>
-              <a:rPr sz="1600" b="1">
-                <a:solidFill>
-                  <a:srgbClr val="1C2330"/>
-                </a:solidFill>
-                <a:latin typeface="Calibri"/>
-              </a:rPr>
-              <a:t>•  Why this category</a:t>
-            </a:r>
-            <a:r>
-              <a:rPr sz="1600">
-                <a:solidFill>
-                  <a:srgbClr val="667085"/>
-                </a:solidFill>
-                <a:latin typeface="Calibri"/>
-              </a:rPr>
-              <a:t> — the AI's reasoning</a:t>
-            </a:r>
-          </a:p>
-          <a:p>
-            <a:pPr>
-              <a:spcAft>
-                <a:spcPts val="1000"/>
-              </a:spcAft>
-            </a:pPr>
-            <a:r>
-              <a:rPr sz="1600" b="1">
-                <a:solidFill>
-                  <a:srgbClr val="1C2330"/>
-                </a:solidFill>
-                <a:latin typeface="Calibri"/>
-              </a:rPr>
-              <a:t>•  Which clause</a:t>
-            </a:r>
-            <a:r>
-              <a:rPr sz="1600">
-                <a:solidFill>
-                  <a:srgbClr val="667085"/>
-                </a:solidFill>
-                <a:latin typeface="Calibri"/>
-              </a:rPr>
-              <a:t> — TEP-2.1 and GE-2.2, with quotes</a:t>
-            </a:r>
-          </a:p>
-          <a:p>
-            <a:pPr>
-              <a:spcAft>
-                <a:spcPts val="1000"/>
-              </a:spcAft>
-            </a:pPr>
-            <a:r>
-              <a:rPr sz="1600" b="1">
-                <a:solidFill>
-                  <a:srgbClr val="1C2330"/>
-                </a:solidFill>
-                <a:latin typeface="Calibri"/>
-              </a:rPr>
-              <a:t>•  What is eligible</a:t>
-            </a:r>
-            <a:r>
-              <a:rPr sz="1600">
-                <a:solidFill>
-                  <a:srgbClr val="667085"/>
-                </a:solidFill>
-                <a:latin typeface="Calibri"/>
-              </a:rPr>
-              <a:t> — ₹5,000 of ₹7,168; excess not reimbursable</a:t>
-            </a:r>
-          </a:p>
-          <a:p>
-            <a:pPr>
-              <a:spcAft>
-                <a:spcPts val="1000"/>
-              </a:spcAft>
-            </a:pPr>
-            <a:r>
-              <a:rPr sz="1600" b="1">
-                <a:solidFill>
-                  <a:srgbClr val="1C2330"/>
-                </a:solidFill>
-                <a:latin typeface="Calibri"/>
-              </a:rPr>
-              <a:t>•  What is needed</a:t>
-            </a:r>
-            <a:r>
-              <a:rPr sz="1600">
-                <a:solidFill>
-                  <a:srgbClr val="667085"/>
-                </a:solidFill>
-                <a:latin typeface="Calibri"/>
-              </a:rPr>
-              <a:t> — shown as a question, once</a:t>
-            </a:r>
-          </a:p>
-        </p:txBody>
-      </p:sp>
-    </p:spTree>
-  </p:cSld>
-  <p:clrMapOvr>
-    <a:masterClrMapping/>
-  </p:clrMapOvr>
-</p:sld>
-</file>
-
-<file path=ppt/slides/slide7.xml><?xml version="1.0" encoding="utf-8"?>
-<p:sld xmlns:a="http://schemas.openxmlformats.org/drawingml/2006/main" xmlns:p="http://schemas.openxmlformats.org/presentationml/2006/main" xmlns:r="http://schemas.openxmlformats.org/officeDocument/2006/relationships">
-  <p:cSld>
-    <p:spTree>
-      <p:nvGrpSpPr>
-        <p:cNvPr id="1" name=""/>
-        <p:cNvGrpSpPr/>
-        <p:nvPr/>
-      </p:nvGrpSpPr>
-      <p:grpSpPr/>
-      <p:sp>
-        <p:nvSpPr>
-          <p:cNvPr id="2" name="Rectangle 1"/>
-          <p:cNvSpPr/>
-          <p:nvPr/>
-        </p:nvSpPr>
-        <p:spPr>
-          <a:xfrm>
-            <a:off x="0" y="0"/>
-            <a:ext cx="228600" cy="6858000"/>
-          </a:xfrm>
-          <a:prstGeom prst="rect">
-            <a:avLst/>
-          </a:prstGeom>
-          <a:solidFill>
-            <a:srgbClr val="1D4ED8"/>
-          </a:solidFill>
-          <a:ln>
-            <a:noFill/>
-          </a:ln>
-        </p:spPr>
-        <p:style>
-          <a:lnRef idx="1">
-            <a:schemeClr val="accent1"/>
-          </a:lnRef>
-          <a:fillRef idx="3">
-            <a:schemeClr val="accent1"/>
-          </a:fillRef>
-          <a:effectRef idx="2">
-            <a:schemeClr val="accent1"/>
-          </a:effectRef>
-          <a:fontRef idx="minor">
-            <a:schemeClr val="lt1"/>
-          </a:fontRef>
-        </p:style>
-        <p:txBody>
-          <a:bodyPr rtlCol="0" anchor="ctr"/>
-          <a:lstStyle/>
-          <a:p>
-            <a:pPr algn="ctr"/>
-          </a:p>
-        </p:txBody>
-      </p:sp>
-      <p:sp>
-        <p:nvSpPr>
-          <p:cNvPr id="3" name="TextBox 2"/>
-          <p:cNvSpPr txBox="1"/>
-          <p:nvPr/>
-        </p:nvSpPr>
-        <p:spPr>
-          <a:xfrm>
-            <a:off x="640080" y="365760"/>
-            <a:ext cx="10972800" cy="822960"/>
-          </a:xfrm>
-          <a:prstGeom prst="rect">
-            <a:avLst/>
-          </a:prstGeom>
-          <a:noFill/>
-        </p:spPr>
-        <p:txBody>
-          <a:bodyPr wrap="square" anchor="t">
-            <a:spAutoFit/>
-          </a:bodyPr>
-          <a:lstStyle/>
-          <a:p>
-            <a:pPr algn="l">
-              <a:spcAft>
-                <a:spcPts val="800"/>
-              </a:spcAft>
-            </a:pPr>
-            <a:r>
-              <a:rPr sz="3200" b="1">
-                <a:solidFill>
-                  <a:srgbClr val="1C2330"/>
-                </a:solidFill>
-                <a:latin typeface="Calibri"/>
-              </a:rPr>
-              <a:t>The experience</a:t>
-            </a:r>
-          </a:p>
-        </p:txBody>
-      </p:sp>
-      <p:sp>
-        <p:nvSpPr>
-          <p:cNvPr id="4" name="TextBox 3"/>
-          <p:cNvSpPr txBox="1"/>
-          <p:nvPr/>
-        </p:nvSpPr>
-        <p:spPr>
-          <a:xfrm>
-            <a:off x="640080" y="1051560"/>
-            <a:ext cx="10972800" cy="457200"/>
-          </a:xfrm>
-          <a:prstGeom prst="rect">
-            <a:avLst/>
-          </a:prstGeom>
-          <a:noFill/>
-        </p:spPr>
-        <p:txBody>
-          <a:bodyPr wrap="square" anchor="t">
-            <a:spAutoFit/>
-          </a:bodyPr>
-          <a:lstStyle/>
-          <a:p>
-            <a:pPr algn="l">
-              <a:spcAft>
-                <a:spcPts val="800"/>
-              </a:spcAft>
-            </a:pPr>
-            <a:r>
-              <a:rPr sz="1600" b="0">
-                <a:solidFill>
-                  <a:srgbClr val="667085"/>
-                </a:solidFill>
-                <a:latin typeface="Calibri"/>
-              </a:rPr>
-              <a:t>Chat on the left, claim on the right</a:t>
-            </a:r>
-          </a:p>
-        </p:txBody>
-      </p:sp>
-      <p:sp>
-        <p:nvSpPr>
-          <p:cNvPr id="5" name="Rounded Rectangle 4"/>
-          <p:cNvSpPr/>
-          <p:nvPr/>
-        </p:nvSpPr>
-        <p:spPr>
-          <a:xfrm>
-            <a:off x="457200" y="1645920"/>
-            <a:ext cx="5852160" cy="4206240"/>
-          </a:xfrm>
-          <a:prstGeom prst="roundRect">
-            <a:avLst/>
-          </a:prstGeom>
-          <a:solidFill>
-            <a:srgbClr val="F2F4F7"/>
-          </a:solidFill>
-          <a:ln>
-            <a:noFill/>
-          </a:ln>
-        </p:spPr>
-        <p:style>
-          <a:lnRef idx="1">
-            <a:schemeClr val="accent1"/>
-          </a:lnRef>
-          <a:fillRef idx="3">
-            <a:schemeClr val="accent1"/>
-          </a:fillRef>
-          <a:effectRef idx="2">
-            <a:schemeClr val="accent1"/>
-          </a:effectRef>
-          <a:fontRef idx="minor">
-            <a:schemeClr val="lt1"/>
-          </a:fontRef>
-        </p:style>
-        <p:txBody>
-          <a:bodyPr rtlCol="0" anchor="ctr"/>
-          <a:lstStyle/>
-          <a:p>
-            <a:pPr algn="ctr"/>
-          </a:p>
-        </p:txBody>
-      </p:sp>
-      <p:sp>
-        <p:nvSpPr>
-          <p:cNvPr id="6" name="TextBox 5"/>
-          <p:cNvSpPr txBox="1"/>
-          <p:nvPr/>
-        </p:nvSpPr>
-        <p:spPr>
-          <a:xfrm>
-            <a:off x="731520" y="3383279"/>
-            <a:ext cx="5303520" cy="914400"/>
-          </a:xfrm>
-          <a:prstGeom prst="rect">
-            <a:avLst/>
-          </a:prstGeom>
-          <a:noFill/>
-        </p:spPr>
-        <p:txBody>
-          <a:bodyPr wrap="square" anchor="t">
-            <a:spAutoFit/>
-          </a:bodyPr>
-          <a:lstStyle/>
-          <a:p>
-            <a:pPr algn="ctr">
-              <a:spcAft>
-                <a:spcPts val="800"/>
-              </a:spcAft>
-            </a:pPr>
-            <a:r>
-              <a:rPr sz="1400" b="0">
-                <a:solidFill>
-                  <a:srgbClr val="667085"/>
-                </a:solidFill>
-                <a:latin typeface="Calibri"/>
-              </a:rPr>
-              <a:t>[screenshot placeholder: 01_claim_and_chat.jpg]</a:t>
-            </a:r>
-          </a:p>
-        </p:txBody>
-      </p:sp>
-      <p:sp>
-        <p:nvSpPr>
-          <p:cNvPr id="7" name="Rounded Rectangle 6"/>
-          <p:cNvSpPr/>
-          <p:nvPr/>
-        </p:nvSpPr>
-        <p:spPr>
-          <a:xfrm>
-            <a:off x="6492240" y="1645920"/>
-            <a:ext cx="5303520" cy="4206240"/>
-          </a:xfrm>
-          <a:prstGeom prst="roundRect">
-            <a:avLst/>
-          </a:prstGeom>
-          <a:solidFill>
-            <a:srgbClr val="F2F4F7"/>
-          </a:solidFill>
-          <a:ln>
-            <a:noFill/>
-          </a:ln>
-        </p:spPr>
-        <p:style>
-          <a:lnRef idx="1">
-            <a:schemeClr val="accent1"/>
-          </a:lnRef>
-          <a:fillRef idx="3">
-            <a:schemeClr val="accent1"/>
-          </a:fillRef>
-          <a:effectRef idx="2">
-            <a:schemeClr val="accent1"/>
-          </a:effectRef>
-          <a:fontRef idx="minor">
-            <a:schemeClr val="lt1"/>
-          </a:fontRef>
-        </p:style>
-        <p:txBody>
-          <a:bodyPr rtlCol="0" anchor="ctr"/>
-          <a:lstStyle/>
-          <a:p>
-            <a:pPr algn="ctr"/>
-          </a:p>
-        </p:txBody>
-      </p:sp>
-      <p:sp>
-        <p:nvSpPr>
-          <p:cNvPr id="8" name="TextBox 7"/>
-          <p:cNvSpPr txBox="1"/>
-          <p:nvPr/>
-        </p:nvSpPr>
-        <p:spPr>
-          <a:xfrm>
-            <a:off x="6766559" y="3383279"/>
-            <a:ext cx="4754880" cy="914400"/>
-          </a:xfrm>
-          <a:prstGeom prst="rect">
-            <a:avLst/>
-          </a:prstGeom>
-          <a:noFill/>
-        </p:spPr>
-        <p:txBody>
-          <a:bodyPr wrap="square" anchor="t">
-            <a:spAutoFit/>
-          </a:bodyPr>
-          <a:lstStyle/>
-          <a:p>
-            <a:pPr algn="ctr">
-              <a:spcAft>
-                <a:spcPts val="800"/>
-              </a:spcAft>
-            </a:pPr>
-            <a:r>
-              <a:rPr sz="1400" b="0">
-                <a:solidFill>
-                  <a:srgbClr val="667085"/>
-                </a:solidFill>
-                <a:latin typeface="Calibri"/>
-              </a:rPr>
-              <a:t>[screenshot placeholder: 05_submitted.jpg]</a:t>
-            </a:r>
-          </a:p>
-        </p:txBody>
-      </p:sp>
-    </p:spTree>
-  </p:cSld>
-  <p:clrMapOvr>
-    <a:masterClrMapping/>
-  </p:clrMapOvr>
-</p:sld>
-</file>
-
-<file path=ppt/slides/slide8.xml><?xml version="1.0" encoding="utf-8"?>
-<p:sld xmlns:a="http://schemas.openxmlformats.org/drawingml/2006/main" xmlns:p="http://schemas.openxmlformats.org/presentationml/2006/main" xmlns:r="http://schemas.openxmlformats.org/officeDocument/2006/relationships">
-  <p:cSld>
-    <p:spTree>
-      <p:nvGrpSpPr>
-        <p:cNvPr id="1" name=""/>
-        <p:cNvGrpSpPr/>
-        <p:nvPr/>
-      </p:nvGrpSpPr>
-      <p:grpSpPr/>
-      <p:sp>
-        <p:nvSpPr>
-          <p:cNvPr id="2" name="Rectangle 1"/>
-          <p:cNvSpPr/>
-          <p:nvPr/>
-        </p:nvSpPr>
-        <p:spPr>
-          <a:xfrm>
-            <a:off x="0" y="0"/>
-            <a:ext cx="228600" cy="6858000"/>
-          </a:xfrm>
-          <a:prstGeom prst="rect">
-            <a:avLst/>
-          </a:prstGeom>
-          <a:solidFill>
-            <a:srgbClr val="1D4ED8"/>
-          </a:solidFill>
-          <a:ln>
-            <a:noFill/>
-          </a:ln>
-        </p:spPr>
-        <p:style>
-          <a:lnRef idx="1">
-            <a:schemeClr val="accent1"/>
-          </a:lnRef>
-          <a:fillRef idx="3">
-            <a:schemeClr val="accent1"/>
-          </a:fillRef>
-          <a:effectRef idx="2">
-            <a:schemeClr val="accent1"/>
-          </a:effectRef>
-          <a:fontRef idx="minor">
-            <a:schemeClr val="lt1"/>
-          </a:fontRef>
-        </p:style>
-        <p:txBody>
-          <a:bodyPr rtlCol="0" anchor="ctr"/>
-          <a:lstStyle/>
-          <a:p>
-            <a:pPr algn="ctr"/>
+            <a:endParaRPr/>
           </a:p>
         </p:txBody>
       </p:sp>
@@ -6974,8 +7054,20 @@
                 <a:tableStyleId>{5C22544A-7EE6-4342-B048-85BDC9FD1C3A}</a:tableStyleId>
               </a:tblPr>
               <a:tblGrid>
-                <a:gridCol w="4572000"/>
-                <a:gridCol w="2743200"/>
+                <a:gridCol w="4572000">
+                  <a:extLst>
+                    <a:ext uri="{9D8B030D-6E8A-4147-A177-3AD203B41FA5}">
+                      <a16:colId xmlns:a16="http://schemas.microsoft.com/office/drawing/2014/main" val="20000"/>
+                    </a:ext>
+                  </a:extLst>
+                </a:gridCol>
+                <a:gridCol w="2743200">
+                  <a:extLst>
+                    <a:ext uri="{9D8B030D-6E8A-4147-A177-3AD203B41FA5}">
+                      <a16:colId xmlns:a16="http://schemas.microsoft.com/office/drawing/2014/main" val="20001"/>
+                    </a:ext>
+                  </a:extLst>
+                </a:gridCol>
               </a:tblGrid>
               <a:tr h="512064">
                 <a:tc>
@@ -7022,6 +7114,11 @@
                     </a:solidFill>
                   </a:tcPr>
                 </a:tc>
+                <a:extLst>
+                  <a:ext uri="{0D108BD9-81ED-4DB2-BD59-A6C34878D82A}">
+                    <a16:rowId xmlns:a16="http://schemas.microsoft.com/office/drawing/2014/main" val="10000"/>
+                  </a:ext>
+                </a:extLst>
               </a:tr>
               <a:tr h="512064">
                 <a:tc>
@@ -7068,6 +7165,11 @@
                     </a:solidFill>
                   </a:tcPr>
                 </a:tc>
+                <a:extLst>
+                  <a:ext uri="{0D108BD9-81ED-4DB2-BD59-A6C34878D82A}">
+                    <a16:rowId xmlns:a16="http://schemas.microsoft.com/office/drawing/2014/main" val="10001"/>
+                  </a:ext>
+                </a:extLst>
               </a:tr>
               <a:tr h="512064">
                 <a:tc>
@@ -7114,6 +7216,11 @@
                     </a:solidFill>
                   </a:tcPr>
                 </a:tc>
+                <a:extLst>
+                  <a:ext uri="{0D108BD9-81ED-4DB2-BD59-A6C34878D82A}">
+                    <a16:rowId xmlns:a16="http://schemas.microsoft.com/office/drawing/2014/main" val="10002"/>
+                  </a:ext>
+                </a:extLst>
               </a:tr>
               <a:tr h="512064">
                 <a:tc>
@@ -7160,6 +7267,11 @@
                     </a:solidFill>
                   </a:tcPr>
                 </a:tc>
+                <a:extLst>
+                  <a:ext uri="{0D108BD9-81ED-4DB2-BD59-A6C34878D82A}">
+                    <a16:rowId xmlns:a16="http://schemas.microsoft.com/office/drawing/2014/main" val="10003"/>
+                  </a:ext>
+                </a:extLst>
               </a:tr>
               <a:tr h="512064">
                 <a:tc>
@@ -7206,6 +7318,11 @@
                     </a:solidFill>
                   </a:tcPr>
                 </a:tc>
+                <a:extLst>
+                  <a:ext uri="{0D108BD9-81ED-4DB2-BD59-A6C34878D82A}">
+                    <a16:rowId xmlns:a16="http://schemas.microsoft.com/office/drawing/2014/main" val="10004"/>
+                  </a:ext>
+                </a:extLst>
               </a:tr>
               <a:tr h="512064">
                 <a:tc>
@@ -7252,6 +7369,11 @@
                     </a:solidFill>
                   </a:tcPr>
                 </a:tc>
+                <a:extLst>
+                  <a:ext uri="{0D108BD9-81ED-4DB2-BD59-A6C34878D82A}">
+                    <a16:rowId xmlns:a16="http://schemas.microsoft.com/office/drawing/2014/main" val="10005"/>
+                  </a:ext>
+                </a:extLst>
               </a:tr>
               <a:tr h="512064">
                 <a:tc>
@@ -7298,6 +7420,11 @@
                     </a:solidFill>
                   </a:tcPr>
                 </a:tc>
+                <a:extLst>
+                  <a:ext uri="{0D108BD9-81ED-4DB2-BD59-A6C34878D82A}">
+                    <a16:rowId xmlns:a16="http://schemas.microsoft.com/office/drawing/2014/main" val="10006"/>
+                  </a:ext>
+                </a:extLst>
               </a:tr>
             </a:tbl>
           </a:graphicData>
@@ -7343,6 +7470,7 @@
           <a:lstStyle/>
           <a:p>
             <a:pPr algn="ctr"/>
+            <a:endParaRPr/>
           </a:p>
         </p:txBody>
       </p:sp>
@@ -7410,7 +7538,7 @@
 </file>
 
 <file path=ppt/slides/slide9.xml><?xml version="1.0" encoding="utf-8"?>
-<p:sld xmlns:a="http://schemas.openxmlformats.org/drawingml/2006/main" xmlns:p="http://schemas.openxmlformats.org/presentationml/2006/main" xmlns:r="http://schemas.openxmlformats.org/officeDocument/2006/relationships">
+<p:sld xmlns:a="http://schemas.openxmlformats.org/drawingml/2006/main" xmlns:r="http://schemas.openxmlformats.org/officeDocument/2006/relationships" xmlns:p="http://schemas.openxmlformats.org/presentationml/2006/main">
   <p:cSld>
     <p:spTree>
       <p:nvGrpSpPr>
@@ -7418,7 +7546,14 @@
         <p:cNvGrpSpPr/>
         <p:nvPr/>
       </p:nvGrpSpPr>
-      <p:grpSpPr/>
+      <p:grpSpPr>
+        <a:xfrm>
+          <a:off x="0" y="0"/>
+          <a:ext cx="0" cy="0"/>
+          <a:chOff x="0" y="0"/>
+          <a:chExt cx="0" cy="0"/>
+        </a:xfrm>
+      </p:grpSpPr>
       <p:sp>
         <p:nvSpPr>
           <p:cNvPr id="2" name="Rectangle 1"/>
@@ -7459,6 +7594,7 @@
           <a:lstStyle/>
           <a:p>
             <a:pPr algn="ctr"/>
+            <a:endParaRPr/>
           </a:p>
         </p:txBody>
       </p:sp>
@@ -7559,8 +7695,20 @@
                 <a:tableStyleId>{5C22544A-7EE6-4342-B048-85BDC9FD1C3A}</a:tableStyleId>
               </a:tblPr>
               <a:tblGrid>
-                <a:gridCol w="4206240"/>
-                <a:gridCol w="2377440"/>
+                <a:gridCol w="4206240">
+                  <a:extLst>
+                    <a:ext uri="{9D8B030D-6E8A-4147-A177-3AD203B41FA5}">
+                      <a16:colId xmlns:a16="http://schemas.microsoft.com/office/drawing/2014/main" val="20000"/>
+                    </a:ext>
+                  </a:extLst>
+                </a:gridCol>
+                <a:gridCol w="2377440">
+                  <a:extLst>
+                    <a:ext uri="{9D8B030D-6E8A-4147-A177-3AD203B41FA5}">
+                      <a16:colId xmlns:a16="http://schemas.microsoft.com/office/drawing/2014/main" val="20001"/>
+                    </a:ext>
+                  </a:extLst>
+                </a:gridCol>
               </a:tblGrid>
               <a:tr h="566928">
                 <a:tc>
@@ -7607,6 +7755,11 @@
                     </a:solidFill>
                   </a:tcPr>
                 </a:tc>
+                <a:extLst>
+                  <a:ext uri="{0D108BD9-81ED-4DB2-BD59-A6C34878D82A}">
+                    <a16:rowId xmlns:a16="http://schemas.microsoft.com/office/drawing/2014/main" val="10000"/>
+                  </a:ext>
+                </a:extLst>
               </a:tr>
               <a:tr h="566928">
                 <a:tc>
@@ -7653,6 +7806,11 @@
                     </a:solidFill>
                   </a:tcPr>
                 </a:tc>
+                <a:extLst>
+                  <a:ext uri="{0D108BD9-81ED-4DB2-BD59-A6C34878D82A}">
+                    <a16:rowId xmlns:a16="http://schemas.microsoft.com/office/drawing/2014/main" val="10001"/>
+                  </a:ext>
+                </a:extLst>
               </a:tr>
               <a:tr h="566928">
                 <a:tc>
@@ -7699,6 +7857,11 @@
                     </a:solidFill>
                   </a:tcPr>
                 </a:tc>
+                <a:extLst>
+                  <a:ext uri="{0D108BD9-81ED-4DB2-BD59-A6C34878D82A}">
+                    <a16:rowId xmlns:a16="http://schemas.microsoft.com/office/drawing/2014/main" val="10002"/>
+                  </a:ext>
+                </a:extLst>
               </a:tr>
               <a:tr h="566928">
                 <a:tc>
@@ -7745,6 +7908,11 @@
                     </a:solidFill>
                   </a:tcPr>
                 </a:tc>
+                <a:extLst>
+                  <a:ext uri="{0D108BD9-81ED-4DB2-BD59-A6C34878D82A}">
+                    <a16:rowId xmlns:a16="http://schemas.microsoft.com/office/drawing/2014/main" val="10003"/>
+                  </a:ext>
+                </a:extLst>
               </a:tr>
             </a:tbl>
           </a:graphicData>

</xml_diff>